<commit_message>
Training films per job: full count and cycle count, English and Spanish
The scanner training is now one film per job, with the scanner offering
that job alone: scanner-training-full-{en,es}.mp4 (under ten minutes, in
the site's bin → pallet → quantity order) and the new
scanner-training-cycle-{en,es}.mp4 (seven and a half minutes: today's
list, a bin with several pallets, an empty bin, help and sign-off). The
stage hides the "Running in the browser" banner, as an installed scanner
does, and the cycle counter is not put on a team, so no "Check the team"
warning appears. Decks rebuilt from the new shots.

Gun: a cycle counter's button reads "My list" (Mi lista) rather than
"My aisle". Screenshots and PDFs regenerated: the sign-on footer without
the scanner details, the crew board card with its shift times.

Co-Authored-By: Claude Fable 5.1 <noreply@anthropic.com>
Claude-Session: https://claude.ai/code/session_01LaCZ626Y2oWoWchJeisbmg
</commit_message>
<xml_diff>
--- a/docs/training/scanner-training-full-en.pptx
+++ b/docs/training/scanner-training-full-en.pptx
@@ -140,26 +140,26 @@
   <p:extLst>
     <p:ext uri="{521415D9-36F7-43E2-AB2F-B90AF26B5E84}">
       <p14:sectionLst xmlns:p14="http://schemas.microsoft.com/office/powerpoint/2010/main">
-        <p14:section name="Start" id="{c13ad500-6f40-f93a-37bc-cab53c127dda}">
+        <p14:section name="Start" id="{b1f5a742-fdd9-db59-f5a5-14b38b7e13ba}">
           <p14:sldIdLst>
             <p14:sldId id="256"/>
           </p14:sldIdLst>
         </p14:section>
-        <p14:section name="Part 1 · Before you start" id="{86233ead-3660-c4b1-6eff-e9acb494adaf}">
+        <p14:section name="Part 1 · Before you start" id="{7ab8c3c0-fef5-59c2-c76f-2f13b666d891}">
           <p14:sldIdLst>
             <p14:sldId id="257"/>
             <p14:sldId id="258"/>
             <p14:sldId id="259"/>
           </p14:sldIdLst>
         </p14:section>
-        <p14:section name="Part 2 · Signing on" id="{04b1d7ae-00d9-b809-594b-f1ce3c38f13c}">
+        <p14:section name="Part 2 · Signing on" id="{af56af35-e731-3755-cca7-194079d01b02}">
           <p14:sldIdLst>
             <p14:sldId id="260"/>
             <p14:sldId id="261"/>
             <p14:sldId id="262"/>
           </p14:sldIdLst>
         </p14:section>
-        <p14:section name="Part 3 · Counting a pallet" id="{ad081d7d-91da-986f-a3b9-cca252e8e416}">
+        <p14:section name="Part 3 · Counting a pallet" id="{7b2a0891-0308-d0ae-3337-d82b0204466d}">
           <p14:sldIdLst>
             <p14:sldId id="263"/>
             <p14:sldId id="264"/>
@@ -170,14 +170,14 @@
             <p14:sldId id="269"/>
           </p14:sldIdLst>
         </p14:section>
-        <p14:section name="Part 4 · When a bin is different" id="{934ad0a2-40e3-c1b5-c7c5-844c3469d697}">
+        <p14:section name="Part 4 · When a bin is different" id="{df4357b2-1968-db40-7f77-ed46fa38f906}">
           <p14:sldIdLst>
             <p14:sldId id="270"/>
             <p14:sldId id="271"/>
             <p14:sldId id="272"/>
           </p14:sldIdLst>
         </p14:section>
-        <p14:section name="Part 5 · Labels" id="{166ddce5-7c51-2538-ec00-d888f036924e}">
+        <p14:section name="Part 5 · Labels" id="{1efd9b38-2a64-7d9e-a383-3a148469bf7b}">
           <p14:sldIdLst>
             <p14:sldId id="273"/>
             <p14:sldId id="274"/>
@@ -186,7 +186,7 @@
             <p14:sldId id="277"/>
           </p14:sldIdLst>
         </p14:section>
-        <p14:section name="Part 6 · Help and fixes" id="{f19e7d20-7d53-724f-b22a-f28dc6075af5}">
+        <p14:section name="Part 6 · Help and fixes" id="{9c6c6f2b-6cb2-b3fe-31d5-1625620c1749}">
           <p14:sldIdLst>
             <p14:sldId id="278"/>
             <p14:sldId id="279"/>
@@ -196,14 +196,14 @@
             <p14:sldId id="283"/>
           </p14:sldIdLst>
         </p14:section>
-        <p14:section name="Part 7 · Second counts, and finishing" id="{72f11aec-8b30-3509-1c0e-5a0adc611557}">
+        <p14:section name="Part 7 · Second counts, and finishing" id="{07cc6484-bead-37f3-5060-042e2b3cbf4f}">
           <p14:sldIdLst>
             <p14:sldId id="284"/>
             <p14:sldId id="285"/>
             <p14:sldId id="286"/>
           </p14:sldIdLst>
         </p14:section>
-        <p14:section name="The rules" id="{6e166927-c27c-ad91-2571-461d2a6af3b2}">
+        <p14:section name="The rules" id="{b6b043f7-da01-57c1-9bdb-ad554fbdaafa}">
           <p14:sldIdLst>
             <p14:sldId id="287"/>
             <p14:sldId id="288"/>
@@ -4652,7 +4652,7 @@
       </p:sp>
       <p:pic>
         <p:nvPicPr>
-          <p:cNvPr id="4" name="screen rack-scanned" descr="/home/user/physical-inv-app/docs/training/shots/en/05-rack-scanned.png">    </p:cNvPr>
+          <p:cNvPr id="4" name="screen rack-scanned" descr="/home/user/physical-inv-app/docs/training/shots/full/en/05-rack-scanned.png">    </p:cNvPr>
           <p:cNvPicPr>
             <a:picLocks noChangeAspect="1"/>
           </p:cNvPicPr>
@@ -4734,7 +4734,7 @@
       </p:sp>
       <p:pic>
         <p:nvPicPr>
-          <p:cNvPr id="6" name="label-rack" descr="/home/user/physical-inv-app/docs/training/shots/en/label-rack.png">    </p:cNvPr>
+          <p:cNvPr id="6" name="label-rack" descr="/home/user/physical-inv-app/docs/training/shots/full/en/label-rack.png">    </p:cNvPr>
           <p:cNvPicPr>
             <a:picLocks noChangeAspect="1"/>
           </p:cNvPicPr>
@@ -4904,7 +4904,7 @@
       </p:sp>
       <p:pic>
         <p:nvPicPr>
-          <p:cNvPr id="4" name="screen pallet-scanned" descr="/home/user/physical-inv-app/docs/training/shots/en/06-pallet-scanned.png">    </p:cNvPr>
+          <p:cNvPr id="4" name="screen pallet-scanned" descr="/home/user/physical-inv-app/docs/training/shots/full/en/06-pallet-scanned.png">    </p:cNvPr>
           <p:cNvPicPr>
             <a:picLocks noChangeAspect="1"/>
           </p:cNvPicPr>
@@ -5016,7 +5016,7 @@
       </p:sp>
       <p:pic>
         <p:nvPicPr>
-          <p:cNvPr id="6" name="label-pallet" descr="/home/user/physical-inv-app/docs/training/shots/en/label-pallet.png">    </p:cNvPr>
+          <p:cNvPr id="6" name="label-pallet" descr="/home/user/physical-inv-app/docs/training/shots/full/en/label-pallet.png">    </p:cNvPr>
           <p:cNvPicPr>
             <a:picLocks noChangeAspect="1"/>
           </p:cNvPicPr>
@@ -5249,7 +5249,7 @@
       </p:sp>
       <p:pic>
         <p:nvPicPr>
-          <p:cNvPr id="4" name="screen quantity" descr="/home/user/physical-inv-app/docs/training/shots/en/07-quantity.png">    </p:cNvPr>
+          <p:cNvPr id="4" name="screen quantity" descr="/home/user/physical-inv-app/docs/training/shots/full/en/07-quantity.png">    </p:cNvPr>
           <p:cNvPicPr>
             <a:picLocks noChangeAspect="1"/>
           </p:cNvPicPr>
@@ -5540,7 +5540,7 @@
       </p:sp>
       <p:pic>
         <p:nvPicPr>
-          <p:cNvPr id="4" name="screen comments" descr="/home/user/physical-inv-app/docs/training/shots/en/08-comments.png">    </p:cNvPr>
+          <p:cNvPr id="4" name="screen comments" descr="/home/user/physical-inv-app/docs/training/shots/full/en/08-comments.png">    </p:cNvPr>
           <p:cNvPicPr>
             <a:picLocks noChangeAspect="1"/>
           </p:cNvPicPr>
@@ -5879,7 +5879,7 @@
       </p:sp>
       <p:pic>
         <p:nvPicPr>
-          <p:cNvPr id="4" name="screen wrong-label" descr="/home/user/physical-inv-app/docs/training/shots/en/09-wrong-label.png">    </p:cNvPr>
+          <p:cNvPr id="4" name="screen wrong-label" descr="/home/user/physical-inv-app/docs/training/shots/full/en/09-wrong-label.png">    </p:cNvPr>
           <p:cNvPicPr>
             <a:picLocks noChangeAspect="1"/>
           </p:cNvPicPr>
@@ -6246,7 +6246,7 @@
       </p:sp>
       <p:pic>
         <p:nvPicPr>
-          <p:cNvPr id="4" name="screen still-in-bin" descr="/home/user/physical-inv-app/docs/training/shots/en/10-still-in-bin.png">    </p:cNvPr>
+          <p:cNvPr id="4" name="screen still-in-bin" descr="/home/user/physical-inv-app/docs/training/shots/full/en/10-still-in-bin.png">    </p:cNvPr>
           <p:cNvPicPr>
             <a:picLocks noChangeAspect="1"/>
           </p:cNvPicPr>
@@ -6615,7 +6615,7 @@
       </p:sp>
       <p:pic>
         <p:nvPicPr>
-          <p:cNvPr id="4" name="screen empty-button" descr="/home/user/physical-inv-app/docs/training/shots/en/11-empty-button.png">    </p:cNvPr>
+          <p:cNvPr id="4" name="screen empty-button" descr="/home/user/physical-inv-app/docs/training/shots/full/en/11-empty-button.png">    </p:cNvPr>
           <p:cNvPicPr>
             <a:picLocks noChangeAspect="1"/>
           </p:cNvPicPr>
@@ -6775,7 +6775,7 @@
       </p:sp>
       <p:pic>
         <p:nvPicPr>
-          <p:cNvPr id="6" name="label-rack" descr="/home/user/physical-inv-app/docs/training/shots/en/label-rack.png">    </p:cNvPr>
+          <p:cNvPr id="6" name="label-rack" descr="/home/user/physical-inv-app/docs/training/shots/full/en/label-rack.png">    </p:cNvPr>
           <p:cNvPicPr>
             <a:picLocks noChangeAspect="1"/>
           </p:cNvPicPr>
@@ -7084,7 +7084,7 @@
       </p:sp>
       <p:pic>
         <p:nvPicPr>
-          <p:cNvPr id="4" name="screen multi-label-button" descr="/home/user/physical-inv-app/docs/training/shots/en/12-multi-label-button.png">    </p:cNvPr>
+          <p:cNvPr id="4" name="screen multi-label-button" descr="/home/user/physical-inv-app/docs/training/shots/full/en/12-multi-label-button.png">    </p:cNvPr>
           <p:cNvPicPr>
             <a:picLocks noChangeAspect="1"/>
           </p:cNvPicPr>
@@ -7108,7 +7108,7 @@
       </p:pic>
       <p:pic>
         <p:nvPicPr>
-          <p:cNvPr id="5" name="screen multi-label-2" descr="/home/user/physical-inv-app/docs/training/shots/en/13-multi-label-2.png">    </p:cNvPr>
+          <p:cNvPr id="5" name="screen multi-label-2" descr="/home/user/physical-inv-app/docs/training/shots/full/en/13-multi-label-2.png">    </p:cNvPr>
           <p:cNvPicPr>
             <a:picLocks noChangeAspect="1"/>
           </p:cNvPicPr>
@@ -7132,7 +7132,7 @@
       </p:pic>
       <p:pic>
         <p:nvPicPr>
-          <p:cNvPr id="6" name="screen multi-label-done" descr="/home/user/physical-inv-app/docs/training/shots/en/14-multi-label-done.png">    </p:cNvPr>
+          <p:cNvPr id="6" name="screen multi-label-done" descr="/home/user/physical-inv-app/docs/training/shots/full/en/14-multi-label-done.png">    </p:cNvPr>
           <p:cNvPicPr>
             <a:picLocks noChangeAspect="1"/>
           </p:cNvPicPr>
@@ -7522,7 +7522,7 @@
       </p:sp>
       <p:pic>
         <p:nvPicPr>
-          <p:cNvPr id="4" name="screen same-label-button" descr="/home/user/physical-inv-app/docs/training/shots/en/15-same-label-button.png">    </p:cNvPr>
+          <p:cNvPr id="4" name="screen same-label-button" descr="/home/user/physical-inv-app/docs/training/shots/full/en/15-same-label-button.png">    </p:cNvPr>
           <p:cNvPicPr>
             <a:picLocks noChangeAspect="1"/>
           </p:cNvPicPr>
@@ -7828,7 +7828,7 @@
       </p:sp>
       <p:pic>
         <p:nvPicPr>
-          <p:cNvPr id="4" name="screen no-scan" descr="/home/user/physical-inv-app/docs/training/shots/en/16-no-scan.png">    </p:cNvPr>
+          <p:cNvPr id="4" name="screen no-scan" descr="/home/user/physical-inv-app/docs/training/shots/full/en/16-no-scan.png">    </p:cNvPr>
           <p:cNvPicPr>
             <a:picLocks noChangeAspect="1"/>
           </p:cNvPicPr>
@@ -8212,7 +8212,7 @@
       </p:sp>
       <p:pic>
         <p:nvPicPr>
-          <p:cNvPr id="4" name="screen not-on-list" descr="/home/user/physical-inv-app/docs/training/shots/en/17-not-on-list.png">    </p:cNvPr>
+          <p:cNvPr id="4" name="screen not-on-list" descr="/home/user/physical-inv-app/docs/training/shots/full/en/17-not-on-list.png">    </p:cNvPr>
           <p:cNvPicPr>
             <a:picLocks noChangeAspect="1"/>
           </p:cNvPicPr>
@@ -8795,7 +8795,7 @@
       </p:sp>
       <p:pic>
         <p:nvPicPr>
-          <p:cNvPr id="4" name="screen history" descr="/home/user/physical-inv-app/docs/training/shots/en/18-history.png">    </p:cNvPr>
+          <p:cNvPr id="4" name="screen history" descr="/home/user/physical-inv-app/docs/training/shots/full/en/18-history.png">    </p:cNvPr>
           <p:cNvPicPr>
             <a:picLocks noChangeAspect="1"/>
           </p:cNvPicPr>
@@ -9113,7 +9113,7 @@
       </p:sp>
       <p:pic>
         <p:nvPicPr>
-          <p:cNvPr id="4" name="screen message" descr="/home/user/physical-inv-app/docs/training/shots/en/19-message.png">    </p:cNvPr>
+          <p:cNvPr id="4" name="screen message" descr="/home/user/physical-inv-app/docs/training/shots/full/en/19-message.png">    </p:cNvPr>
           <p:cNvPicPr>
             <a:picLocks noChangeAspect="1"/>
           </p:cNvPicPr>
@@ -9371,7 +9371,7 @@
       </p:sp>
       <p:pic>
         <p:nvPicPr>
-          <p:cNvPr id="4" name="screen offline" descr="/home/user/physical-inv-app/docs/training/shots/en/20-offline.png">    </p:cNvPr>
+          <p:cNvPr id="4" name="screen offline" descr="/home/user/physical-inv-app/docs/training/shots/full/en/20-offline.png">    </p:cNvPr>
           <p:cNvPicPr>
             <a:picLocks noChangeAspect="1"/>
           </p:cNvPicPr>
@@ -9725,7 +9725,7 @@
       </p:sp>
       <p:pic>
         <p:nvPicPr>
-          <p:cNvPr id="4" name="screen report-problem" descr="/home/user/physical-inv-app/docs/training/shots/en/21-report-problem.png">    </p:cNvPr>
+          <p:cNvPr id="4" name="screen report-problem" descr="/home/user/physical-inv-app/docs/training/shots/full/en/21-report-problem.png">    </p:cNvPr>
           <p:cNvPicPr>
             <a:picLocks noChangeAspect="1"/>
           </p:cNvPicPr>
@@ -10031,7 +10031,7 @@
       </p:sp>
       <p:pic>
         <p:nvPicPr>
-          <p:cNvPr id="4" name="screen sos-list" descr="/home/user/physical-inv-app/docs/training/shots/en/22-sos-list.png">    </p:cNvPr>
+          <p:cNvPr id="4" name="screen sos-list" descr="/home/user/physical-inv-app/docs/training/shots/full/en/22-sos-list.png">    </p:cNvPr>
           <p:cNvPicPr>
             <a:picLocks noChangeAspect="1"/>
           </p:cNvPicPr>
@@ -10055,7 +10055,7 @@
       </p:pic>
       <p:pic>
         <p:nvPicPr>
-          <p:cNvPr id="5" name="screen sos-seen" descr="/home/user/physical-inv-app/docs/training/shots/en/23-sos-seen.png">    </p:cNvPr>
+          <p:cNvPr id="5" name="screen sos-seen" descr="/home/user/physical-inv-app/docs/training/shots/full/en/23-sos-seen.png">    </p:cNvPr>
           <p:cNvPicPr>
             <a:picLocks noChangeAspect="1"/>
           </p:cNvPicPr>
@@ -10533,7 +10533,7 @@
       </p:sp>
       <p:pic>
         <p:nvPicPr>
-          <p:cNvPr id="4" name="screen signon" descr="/home/user/physical-inv-app/docs/training/shots/en/01-signon.png">    </p:cNvPr>
+          <p:cNvPr id="4" name="screen signon" descr="/home/user/physical-inv-app/docs/training/shots/full/en/01-signon.png">    </p:cNvPr>
           <p:cNvPicPr>
             <a:picLocks noChangeAspect="1"/>
           </p:cNvPicPr>
@@ -10887,7 +10887,7 @@
       </p:sp>
       <p:pic>
         <p:nvPicPr>
-          <p:cNvPr id="4" name="screen second-counts-offered" descr="/home/user/physical-inv-app/docs/training/shots/en/24-second-counts-offered.png">    </p:cNvPr>
+          <p:cNvPr id="4" name="screen second-counts-offered" descr="/home/user/physical-inv-app/docs/training/shots/full/en/24-second-counts-offered.png">    </p:cNvPr>
           <p:cNvPicPr>
             <a:picLocks noChangeAspect="1"/>
           </p:cNvPicPr>
@@ -10911,7 +10911,7 @@
       </p:pic>
       <p:pic>
         <p:nvPicPr>
-          <p:cNvPr id="5" name="screen second-count" descr="/home/user/physical-inv-app/docs/training/shots/en/25-second-count.png">    </p:cNvPr>
+          <p:cNvPr id="5" name="screen second-count" descr="/home/user/physical-inv-app/docs/training/shots/full/en/25-second-count.png">    </p:cNvPr>
           <p:cNvPicPr>
             <a:picLocks noChangeAspect="1"/>
           </p:cNvPicPr>
@@ -11310,7 +11310,7 @@
       </p:sp>
       <p:pic>
         <p:nvPicPr>
-          <p:cNvPr id="4" name="screen aisle-complete" descr="/home/user/physical-inv-app/docs/training/shots/en/26-aisle-complete.png">    </p:cNvPr>
+          <p:cNvPr id="4" name="screen aisle-complete" descr="/home/user/physical-inv-app/docs/training/shots/full/en/26-aisle-complete.png">    </p:cNvPr>
           <p:cNvPicPr>
             <a:picLocks noChangeAspect="1"/>
           </p:cNvPicPr>
@@ -11334,7 +11334,7 @@
       </p:pic>
       <p:pic>
         <p:nvPicPr>
-          <p:cNvPr id="5" name="screen next-aisle" descr="/home/user/physical-inv-app/docs/training/shots/en/27-next-aisle.png">    </p:cNvPr>
+          <p:cNvPr id="5" name="screen next-aisle" descr="/home/user/physical-inv-app/docs/training/shots/full/en/27-next-aisle.png">    </p:cNvPr>
           <p:cNvPicPr>
             <a:picLocks noChangeAspect="1"/>
           </p:cNvPicPr>
@@ -11652,7 +11652,7 @@
       </p:sp>
       <p:pic>
         <p:nvPicPr>
-          <p:cNvPr id="4" name="screen next-bin" descr="/home/user/physical-inv-app/docs/training/shots/en/04-next-bin.png">    </p:cNvPr>
+          <p:cNvPr id="4" name="screen next-bin" descr="/home/user/physical-inv-app/docs/training/shots/full/en/04-next-bin.png">    </p:cNvPr>
           <p:cNvPicPr>
             <a:picLocks noChangeAspect="1"/>
           </p:cNvPicPr>
@@ -13970,7 +13970,7 @@
       </p:sp>
       <p:pic>
         <p:nvPicPr>
-          <p:cNvPr id="4" name="screen signon" descr="/home/user/physical-inv-app/docs/training/shots/en/01-signon.png">    </p:cNvPr>
+          <p:cNvPr id="4" name="screen signon" descr="/home/user/physical-inv-app/docs/training/shots/full/en/01-signon.png">    </p:cNvPr>
           <p:cNvPicPr>
             <a:picLocks noChangeAspect="1"/>
           </p:cNvPicPr>
@@ -14385,7 +14385,7 @@
       </p:sp>
       <p:pic>
         <p:nvPicPr>
-          <p:cNvPr id="4" name="screen signon-filled" descr="/home/user/physical-inv-app/docs/training/shots/en/02-signon-filled.png">    </p:cNvPr>
+          <p:cNvPr id="4" name="screen signon-filled" descr="/home/user/physical-inv-app/docs/training/shots/full/en/02-signon-filled.png">    </p:cNvPr>
           <p:cNvPicPr>
             <a:picLocks noChangeAspect="1"/>
           </p:cNvPicPr>
@@ -14620,7 +14620,7 @@
       </p:sp>
       <p:pic>
         <p:nvPicPr>
-          <p:cNvPr id="6" name="label-team" descr="/home/user/physical-inv-app/docs/training/shots/en/label-team.png">    </p:cNvPr>
+          <p:cNvPr id="6" name="label-team" descr="/home/user/physical-inv-app/docs/training/shots/full/en/label-team.png">    </p:cNvPr>
           <p:cNvPicPr>
             <a:picLocks noChangeAspect="1"/>
           </p:cNvPicPr>
@@ -14644,7 +14644,7 @@
       </p:pic>
       <p:pic>
         <p:nvPicPr>
-          <p:cNvPr id="7" name="label-badge" descr="/home/user/physical-inv-app/docs/training/shots/en/label-badge.png">    </p:cNvPr>
+          <p:cNvPr id="7" name="label-badge" descr="/home/user/physical-inv-app/docs/training/shots/full/en/label-badge.png">    </p:cNvPr>
           <p:cNvPicPr>
             <a:picLocks noChangeAspect="1"/>
           </p:cNvPicPr>
@@ -14814,7 +14814,7 @@
       </p:sp>
       <p:pic>
         <p:nvPicPr>
-          <p:cNvPr id="4" name="screen your-aisle" descr="/home/user/physical-inv-app/docs/training/shots/en/03-your-aisle.png">    </p:cNvPr>
+          <p:cNvPr id="4" name="screen your-aisle" descr="/home/user/physical-inv-app/docs/training/shots/full/en/03-your-aisle.png">    </p:cNvPr>
           <p:cNvPicPr>
             <a:picLocks noChangeAspect="1"/>
           </p:cNvPicPr>
@@ -15292,7 +15292,7 @@
       </p:sp>
       <p:pic>
         <p:nvPicPr>
-          <p:cNvPr id="4" name="screen next-bin" descr="/home/user/physical-inv-app/docs/training/shots/en/04-next-bin.png">    </p:cNvPr>
+          <p:cNvPr id="4" name="screen next-bin" descr="/home/user/physical-inv-app/docs/training/shots/full/en/04-next-bin.png">    </p:cNvPr>
           <p:cNvPicPr>
             <a:picLocks noChangeAspect="1"/>
           </p:cNvPicPr>

</xml_diff>

<commit_message>
Fix round: films, decks, screenshots and PDFs regenerated
The full-count films now show the aisle finished from the office (the
supervisor marks it done, the next aisle appears on My aisle); decks
rebuilt from the new shots; SOP and guide screenshots and PDFs refreshed.
The messages suite expects the cursor in Team number at sign-on.

Co-Authored-By: Claude Fable 5.1 <noreply@anthropic.com>
Claude-Session: https://claude.ai/code/session_01LaCZ626Y2oWoWchJeisbmg
</commit_message>
<xml_diff>
--- a/docs/training/scanner-training-full-en.pptx
+++ b/docs/training/scanner-training-full-en.pptx
@@ -140,26 +140,26 @@
   <p:extLst>
     <p:ext uri="{521415D9-36F7-43E2-AB2F-B90AF26B5E84}">
       <p14:sectionLst xmlns:p14="http://schemas.microsoft.com/office/powerpoint/2010/main">
-        <p14:section name="Start" id="{b1f5a742-fdd9-db59-f5a5-14b38b7e13ba}">
+        <p14:section name="Start" id="{d1ffcc8f-9db8-44b4-4340-43976bddf834}">
           <p14:sldIdLst>
             <p14:sldId id="256"/>
           </p14:sldIdLst>
         </p14:section>
-        <p14:section name="Part 1 · Before you start" id="{7ab8c3c0-fef5-59c2-c76f-2f13b666d891}">
+        <p14:section name="Part 1 · Before you start" id="{32161e35-df45-118a-d3cf-ea86c63bae4c}">
           <p14:sldIdLst>
             <p14:sldId id="257"/>
             <p14:sldId id="258"/>
             <p14:sldId id="259"/>
           </p14:sldIdLst>
         </p14:section>
-        <p14:section name="Part 2 · Signing on" id="{af56af35-e731-3755-cca7-194079d01b02}">
+        <p14:section name="Part 2 · Signing on" id="{e2dbd654-5ec0-2e70-b04e-8ee99df452c9}">
           <p14:sldIdLst>
             <p14:sldId id="260"/>
             <p14:sldId id="261"/>
             <p14:sldId id="262"/>
           </p14:sldIdLst>
         </p14:section>
-        <p14:section name="Part 3 · Counting a pallet" id="{7b2a0891-0308-d0ae-3337-d82b0204466d}">
+        <p14:section name="Part 3 · Counting a pallet" id="{46b4b5d2-4850-a210-d8c3-322091a31a57}">
           <p14:sldIdLst>
             <p14:sldId id="263"/>
             <p14:sldId id="264"/>
@@ -170,14 +170,14 @@
             <p14:sldId id="269"/>
           </p14:sldIdLst>
         </p14:section>
-        <p14:section name="Part 4 · When a bin is different" id="{df4357b2-1968-db40-7f77-ed46fa38f906}">
+        <p14:section name="Part 4 · When a bin is different" id="{1cfff933-aab6-a84a-4a6b-83e5dfb0befb}">
           <p14:sldIdLst>
             <p14:sldId id="270"/>
             <p14:sldId id="271"/>
             <p14:sldId id="272"/>
           </p14:sldIdLst>
         </p14:section>
-        <p14:section name="Part 5 · Labels" id="{1efd9b38-2a64-7d9e-a383-3a148469bf7b}">
+        <p14:section name="Part 5 · Labels" id="{14cef3a6-859e-88ea-653d-f82651449987}">
           <p14:sldIdLst>
             <p14:sldId id="273"/>
             <p14:sldId id="274"/>
@@ -186,7 +186,7 @@
             <p14:sldId id="277"/>
           </p14:sldIdLst>
         </p14:section>
-        <p14:section name="Part 6 · Help and fixes" id="{9c6c6f2b-6cb2-b3fe-31d5-1625620c1749}">
+        <p14:section name="Part 6 · Help and fixes" id="{e28304b6-8521-769f-333d-6859892af0eb}">
           <p14:sldIdLst>
             <p14:sldId id="278"/>
             <p14:sldId id="279"/>
@@ -196,14 +196,14 @@
             <p14:sldId id="283"/>
           </p14:sldIdLst>
         </p14:section>
-        <p14:section name="Part 7 · Second counts, and finishing" id="{07cc6484-bead-37f3-5060-042e2b3cbf4f}">
+        <p14:section name="Part 7 · Second counts, and finishing" id="{46ce1aed-9bca-dde5-e29f-b1958537575c}">
           <p14:sldIdLst>
             <p14:sldId id="284"/>
             <p14:sldId id="285"/>
             <p14:sldId id="286"/>
           </p14:sldIdLst>
         </p14:section>
-        <p14:section name="The rules" id="{b6b043f7-da01-57c1-9bdb-ad554fbdaafa}">
+        <p14:section name="The rules" id="{6ba93f1e-2f4c-16d4-ce47-6d508df6374d}">
           <p14:sldIdLst>
             <p14:sldId id="287"/>
             <p14:sldId id="288"/>
@@ -11390,7 +11390,7 @@
                   <a:schemeClr val="bg2"/>
                 </a:solidFill>
               </a:rPr>
-              <a:t>Only when every spot on your levels is counted: open </a:t>
+              <a:t>When every spot on your levels is counted, </a:t>
             </a:r>
             <a:pPr algn="l" marL="228600" indent="-228600">
               <a:spcAft>
@@ -11405,7 +11405,7 @@
                   <a:schemeClr val="bg2"/>
                 </a:solidFill>
               </a:rPr>
-              <a:t>My aisle</a:t>
+              <a:t>tell your supervisor</a:t>
             </a:r>
             <a:pPr algn="l" marL="228600" indent="-228600">
               <a:spcAft>
@@ -11420,7 +11420,7 @@
                   <a:schemeClr val="bg2"/>
                 </a:solidFill>
               </a:rPr>
-              <a:t> and tap </a:t>
+              <a:t>. They mark the aisle done in the office — no button on the scanner — and your next aisle appears on </a:t>
             </a:r>
             <a:pPr algn="l" marL="228600" indent="-228600">
               <a:spcAft>
@@ -11435,7 +11435,7 @@
                   <a:schemeClr val="bg2"/>
                 </a:solidFill>
               </a:rPr>
-              <a:t>Aisle complete — next aisle</a:t>
+              <a:t>My aisle</a:t>
             </a:r>
             <a:pPr algn="l" marL="228600" indent="-228600">
               <a:spcAft>
@@ -11450,7 +11450,7 @@
                   <a:schemeClr val="bg2"/>
                 </a:solidFill>
               </a:rPr>
-              <a:t>. The scanner gives you the next one.</a:t>
+              <a:t> by itself.</a:t>
             </a:r>
             <a:endParaRPr lang="en-US" sz="2200" dirty="0"/>
           </a:p>
@@ -13269,7 +13269,7 @@
                           <a:ea typeface="+mn-lt" pitchFamily="34" charset="-122"/>
                           <a:cs typeface="+mn-lt" pitchFamily="34" charset="-120"/>
                         </a:rPr>
-                        <a:t>Aisle complete — next aisle</a:t>
+                        <a:t>Refresh, on My aisle</a:t>
                       </a:r>
                       <a:endParaRPr lang="en-US" sz="1400" dirty="0">
                         <a:latin typeface="+mn-lt" charset="0"/>
@@ -13337,7 +13337,7 @@
                           <a:ea typeface="+mn-lt" pitchFamily="34" charset="-122"/>
                           <a:cs typeface="+mn-lt" pitchFamily="34" charset="-120"/>
                         </a:rPr>
-                        <a:t>Only when the whole aisle is counted</a:t>
+                        <a:t>Your next aisle, once the supervisor marks this one done</a:t>
                       </a:r>
                       <a:endParaRPr lang="en-US" sz="1400" dirty="0">
                         <a:latin typeface="+mn-lt" charset="0"/>

</xml_diff>

<commit_message>
Gun: History is the team's own and a void sends them back; a training roster
History on the scanner shows only the signed-on team's lines, in the last twenty
bins it scanned - not the crew before them. Voiding a line takes the team back to
that bin: the guide says "Go back to", the message says what to scan, and a count
landing there ends it. An EMPTY that is voided reopens the bin; the echo of a
voided line in the server's counted list is not a duplicate. A new crew starts
clean at sign-on and sign-off, not in the bin the last crew left off in.

Classroom training: a roster of the uploaded employees to tick off as they finish
the wall, with who ticked them and when, by shift, as a clipboard sheet and a CSV.
The films and decks re-made on this build; the trainer's key, the guide, the SOP
and the README say what the gun really does.

Co-Authored-By: Claude Fable 5.1 <noreply@anthropic.com>
Claude-Session: https://claude.ai/code/session_01LaCZ626Y2oWoWchJeisbmg
</commit_message>
<xml_diff>
--- a/docs/training/scanner-training-full-en.pptx
+++ b/docs/training/scanner-training-full-en.pptx
@@ -143,27 +143,27 @@
   <p:extLst>
     <p:ext uri="{521415D9-36F7-43E2-AB2F-B90AF26B5E84}">
       <p14:sectionLst xmlns:p14="http://schemas.microsoft.com/office/powerpoint/2010/main">
-        <p14:section name="Start" id="{64f79d78-0b0b-1879-c09f-e871a51d558b}">
+        <p14:section name="Start" id="{69a1b8d1-251c-0679-c01f-ae20e46f9f10}">
           <p14:sldIdLst>
             <p14:sldId id="256"/>
             <p14:sldId id="257"/>
           </p14:sldIdLst>
         </p14:section>
-        <p14:section name="Part 1 · Before you start" id="{96b53aba-42d6-0963-d0cd-f773dd871876}">
+        <p14:section name="Part 1 · Before you start" id="{18ce2c4d-103c-5d00-f5b1-2842e903eb3a}">
           <p14:sldIdLst>
             <p14:sldId id="258"/>
             <p14:sldId id="259"/>
             <p14:sldId id="260"/>
           </p14:sldIdLst>
         </p14:section>
-        <p14:section name="Part 2 · Signing on" id="{52d2dd88-b3ec-ac9f-2c74-5f12c5d7e9e7}">
+        <p14:section name="Part 2 · Signing on" id="{61bc6c7a-5db9-3786-27d5-c2781850b0b0}">
           <p14:sldIdLst>
             <p14:sldId id="261"/>
             <p14:sldId id="262"/>
             <p14:sldId id="263"/>
           </p14:sldIdLst>
         </p14:section>
-        <p14:section name="Part 3 · Counting a pallet" id="{62068685-da9e-7d67-f084-cec8c9fd044b}">
+        <p14:section name="Part 3 · Counting a pallet" id="{ab18e94e-0b8f-b103-3406-c72ab764b95f}">
           <p14:sldIdLst>
             <p14:sldId id="264"/>
             <p14:sldId id="265"/>
@@ -174,14 +174,14 @@
             <p14:sldId id="270"/>
           </p14:sldIdLst>
         </p14:section>
-        <p14:section name="Part 4 · When a bin is different" id="{c04314a9-082f-70a1-2d9f-8ed8803583d0}">
+        <p14:section name="Part 4 · When a bin is different" id="{e0b1caa7-fc88-1f4d-7d6c-8272cea92d8a}">
           <p14:sldIdLst>
             <p14:sldId id="271"/>
             <p14:sldId id="272"/>
             <p14:sldId id="273"/>
           </p14:sldIdLst>
         </p14:section>
-        <p14:section name="Part 5 · Labels" id="{0363373d-d118-2737-193b-f99c5e493e42}">
+        <p14:section name="Part 5 · Labels" id="{094e2677-cd4e-0fc2-a3bb-af26dec5f916}">
           <p14:sldIdLst>
             <p14:sldId id="274"/>
             <p14:sldId id="275"/>
@@ -190,7 +190,7 @@
             <p14:sldId id="278"/>
           </p14:sldIdLst>
         </p14:section>
-        <p14:section name="Part 6 · Help and fixes" id="{d2f17f11-5d93-2bf1-04b9-4981206f3727}">
+        <p14:section name="Part 6 · Help and fixes" id="{ccee7d7a-0609-c280-fe6e-6d4937ed2fc7}">
           <p14:sldIdLst>
             <p14:sldId id="279"/>
             <p14:sldId id="280"/>
@@ -200,14 +200,14 @@
             <p14:sldId id="284"/>
           </p14:sldIdLst>
         </p14:section>
-        <p14:section name="Part 7 · Second counts, and finishing" id="{d06688e1-29fe-56bd-9d5c-e05820cbd317}">
+        <p14:section name="Part 7 · Second counts, and finishing" id="{27ce8875-eb70-1fcc-40a7-e25a65f58b87}">
           <p14:sldIdLst>
             <p14:sldId id="285"/>
             <p14:sldId id="286"/>
             <p14:sldId id="287"/>
           </p14:sldIdLst>
         </p14:section>
-        <p14:section name="The rules" id="{dc0e1dcf-814f-37f6-b500-cc9271dd291d}">
+        <p14:section name="The rules" id="{b3c3824a-763a-953d-0bb9-f742e80986e7}">
           <p14:sldIdLst>
             <p14:sldId id="288"/>
             <p14:sldId id="289"/>
@@ -10364,7 +10364,7 @@
                   <a:schemeClr val="bg2"/>
                 </a:solidFill>
               </a:rPr>
-              <a:t> — your last 50 lines. </a:t>
+              <a:t> — your team’s lines in the last 20 bins. </a:t>
             </a:r>
             <a:pPr algn="l" marL="228600" indent="-228600">
               <a:spcAft>
@@ -10394,7 +10394,7 @@
                   <a:schemeClr val="bg2"/>
                 </a:solidFill>
               </a:rPr>
-              <a:t> takes a wrong one out.</a:t>
+              <a:t> takes a wrong one out and sends you back to that bin.</a:t>
             </a:r>
             <a:endParaRPr lang="en-US" sz="2200" dirty="0"/>
           </a:p>

</xml_diff>